<commit_message>
CPS-uses slide as two lettered bullet groups instead of a table
Co-Authored-By: Claude Fable 5 <noreply@anthropic.com>
Claude-Session: https://claude.ai/code/session_01DNzQPDcr3zfLTraMHUHqUn
</commit_message>
<xml_diff>
--- a/report/data_cluster/cps_uses_slide.pptx
+++ b/report/data_cluster/cps_uses_slide.pptx
@@ -3097,7 +3097,7 @@
         <p:spPr>
           <a:xfrm>
             <a:off x="502920" y="219456"/>
-            <a:ext cx="11247120" cy="365760"/>
+            <a:ext cx="11247120" cy="914400"/>
           </a:xfrm>
           <a:prstGeom prst="rect">
             <a:avLst/>
@@ -3114,6 +3114,9 @@
               <a:lnSpc>
                 <a:spcPts val="3584"/>
               </a:lnSpc>
+              <a:spcAft>
+                <a:spcPts val="0"/>
+              </a:spcAft>
             </a:pPr>
             <a:r>
               <a:rPr sz="2800" b="1">
@@ -3127,52 +3130,16 @@
           </a:p>
         </p:txBody>
       </p:sp>
-      <p:cxnSp>
-        <p:nvCxnSpPr>
-          <p:cNvPr id="3" name="Connector 2"/>
-          <p:cNvCxnSpPr/>
+      <p:sp>
+        <p:nvSpPr>
+          <p:cNvPr id="3" name="TextBox 2"/>
+          <p:cNvSpPr txBox="1"/>
           <p:nvPr/>
-        </p:nvCxnSpPr>
+        </p:nvSpPr>
         <p:spPr>
           <a:xfrm>
-            <a:off x="822960" y="1591056"/>
-            <a:ext cx="10607040" cy="0"/>
-          </a:xfrm>
-          <a:prstGeom prst="line">
-            <a:avLst/>
-          </a:prstGeom>
-          <a:ln w="12700">
-            <a:solidFill>
-              <a:srgbClr val="212529"/>
-            </a:solidFill>
-          </a:ln>
-          <a:effectLst/>
-        </p:spPr>
-        <p:style>
-          <a:lnRef idx="2">
-            <a:schemeClr val="accent1"/>
-          </a:lnRef>
-          <a:fillRef idx="0">
-            <a:schemeClr val="accent1"/>
-          </a:fillRef>
-          <a:effectRef idx="1">
-            <a:schemeClr val="accent1"/>
-          </a:effectRef>
-          <a:fontRef idx="minor">
-            <a:schemeClr val="tx1"/>
-          </a:fontRef>
-        </p:style>
-      </p:cxnSp>
-      <p:sp>
-        <p:nvSpPr>
-          <p:cNvPr id="4" name="TextBox 3"/>
-          <p:cNvSpPr txBox="1"/>
-          <p:nvPr/>
-        </p:nvSpPr>
-        <p:spPr>
-          <a:xfrm>
-            <a:off x="822960" y="1645920"/>
-            <a:ext cx="2743200" cy="365760"/>
+            <a:off x="822960" y="1417320"/>
+            <a:ext cx="10789920" cy="914400"/>
           </a:xfrm>
           <a:prstGeom prst="rect">
             <a:avLst/>
@@ -3187,31 +3154,43 @@
           <a:p>
             <a:pPr>
               <a:lnSpc>
-                <a:spcPts val="1855"/>
+                <a:spcPts val="2560"/>
               </a:lnSpc>
+              <a:spcAft>
+                <a:spcPts val="800"/>
+              </a:spcAft>
             </a:pPr>
             <a:r>
-              <a:rPr sz="1450" b="1">
-                <a:solidFill>
-                  <a:srgbClr val="212529"/>
+              <a:rPr sz="2000" b="1">
+                <a:solidFill>
+                  <a:srgbClr val="2D6CB5"/>
                 </a:solidFill>
                 <a:latin typeface="Garamond"/>
               </a:rPr>
-              <a:t>Instrument</a:t>
-            </a:r>
-          </a:p>
-        </p:txBody>
-      </p:sp>
-      <p:sp>
-        <p:nvSpPr>
-          <p:cNvPr id="5" name="TextBox 4"/>
+              <a:t>▪  </a:t>
+            </a:r>
+            <a:r>
+              <a:rPr sz="2000" b="0">
+                <a:solidFill>
+                  <a:srgbClr val="212529"/>
+                </a:solidFill>
+                <a:latin typeface="Garamond"/>
+              </a:rPr>
+              <a:t>The basic monthly survey produces:</a:t>
+            </a:r>
+          </a:p>
+        </p:txBody>
+      </p:sp>
+      <p:sp>
+        <p:nvSpPr>
+          <p:cNvPr id="4" name="TextBox 3"/>
           <p:cNvSpPr txBox="1"/>
           <p:nvPr/>
         </p:nvSpPr>
         <p:spPr>
           <a:xfrm>
-            <a:off x="3749039" y="1645920"/>
-            <a:ext cx="3931920" cy="365760"/>
+            <a:off x="1417320" y="2011680"/>
+            <a:ext cx="9966960" cy="914400"/>
           </a:xfrm>
           <a:prstGeom prst="rect">
             <a:avLst/>
@@ -3226,31 +3205,99 @@
           <a:p>
             <a:pPr>
               <a:lnSpc>
-                <a:spcPts val="1855"/>
+                <a:spcPts val="2432"/>
               </a:lnSpc>
+              <a:spcAft>
+                <a:spcPts val="600"/>
+              </a:spcAft>
             </a:pPr>
             <a:r>
-              <a:rPr sz="1450" b="1">
-                <a:solidFill>
-                  <a:srgbClr val="212529"/>
+              <a:rPr sz="1900" b="1">
+                <a:solidFill>
+                  <a:srgbClr val="102D5E"/>
                 </a:solidFill>
                 <a:latin typeface="Garamond"/>
               </a:rPr>
-              <a:t>What it asks</a:t>
-            </a:r>
-          </a:p>
-        </p:txBody>
-      </p:sp>
-      <p:sp>
-        <p:nvSpPr>
-          <p:cNvPr id="6" name="TextBox 5"/>
+              <a:t>(a)  </a:t>
+            </a:r>
+            <a:r>
+              <a:rPr sz="1900" b="0">
+                <a:solidFill>
+                  <a:srgbClr val="212529"/>
+                </a:solidFill>
+                <a:latin typeface="Garamond"/>
+              </a:rPr>
+              <a:t>The official monthly unemployment rate</a:t>
+            </a:r>
+          </a:p>
+          <a:p>
+            <a:pPr>
+              <a:lnSpc>
+                <a:spcPts val="2432"/>
+              </a:lnSpc>
+              <a:spcAft>
+                <a:spcPts val="600"/>
+              </a:spcAft>
+            </a:pPr>
+            <a:r>
+              <a:rPr sz="1900" b="1">
+                <a:solidFill>
+                  <a:srgbClr val="102D5E"/>
+                </a:solidFill>
+                <a:latin typeface="Garamond"/>
+              </a:rPr>
+              <a:t>(b)  </a:t>
+            </a:r>
+            <a:r>
+              <a:rPr sz="1900" b="0">
+                <a:solidFill>
+                  <a:srgbClr val="212529"/>
+                </a:solidFill>
+                <a:latin typeface="Garamond"/>
+              </a:rPr>
+              <a:t>The official employment and earnings statistics</a:t>
+            </a:r>
+          </a:p>
+          <a:p>
+            <a:pPr>
+              <a:lnSpc>
+                <a:spcPts val="2432"/>
+              </a:lnSpc>
+              <a:spcAft>
+                <a:spcPts val="600"/>
+              </a:spcAft>
+            </a:pPr>
+            <a:r>
+              <a:rPr sz="1900" b="1">
+                <a:solidFill>
+                  <a:srgbClr val="102D5E"/>
+                </a:solidFill>
+                <a:latin typeface="Garamond"/>
+              </a:rPr>
+              <a:t>(c)  </a:t>
+            </a:r>
+            <a:r>
+              <a:rPr sz="1900" b="0">
+                <a:solidFill>
+                  <a:srgbClr val="212529"/>
+                </a:solidFill>
+                <a:latin typeface="Garamond"/>
+              </a:rPr>
+              <a:t>Topic-specific official statistics, through its monthly supplements (school enrollment, voting, tobacco, computer use)</a:t>
+            </a:r>
+          </a:p>
+        </p:txBody>
+      </p:sp>
+      <p:sp>
+        <p:nvSpPr>
+          <p:cNvPr id="5" name="TextBox 4"/>
           <p:cNvSpPr txBox="1"/>
           <p:nvPr/>
         </p:nvSpPr>
         <p:spPr>
           <a:xfrm>
-            <a:off x="7863840" y="1645920"/>
-            <a:ext cx="3566160" cy="365760"/>
+            <a:off x="822960" y="3520440"/>
+            <a:ext cx="10789920" cy="914400"/>
           </a:xfrm>
           <a:prstGeom prst="rect">
             <a:avLst/>
@@ -3265,67 +3312,43 @@
           <a:p>
             <a:pPr>
               <a:lnSpc>
-                <a:spcPts val="1855"/>
+                <a:spcPts val="2560"/>
               </a:lnSpc>
+              <a:spcAft>
+                <a:spcPts val="800"/>
+              </a:spcAft>
             </a:pPr>
             <a:r>
-              <a:rPr sz="1450" b="1">
-                <a:solidFill>
-                  <a:srgbClr val="212529"/>
+              <a:rPr sz="2000" b="1">
+                <a:solidFill>
+                  <a:srgbClr val="2D6CB5"/>
                 </a:solidFill>
                 <a:latin typeface="Garamond"/>
               </a:rPr>
-              <a:t>What it produces</a:t>
-            </a:r>
-          </a:p>
-        </p:txBody>
-      </p:sp>
-      <p:cxnSp>
-        <p:nvCxnSpPr>
-          <p:cNvPr id="7" name="Connector 6"/>
-          <p:cNvCxnSpPr/>
+              <a:t>▪  </a:t>
+            </a:r>
+            <a:r>
+              <a:rPr sz="2000" b="0">
+                <a:solidFill>
+                  <a:srgbClr val="212529"/>
+                </a:solidFill>
+                <a:latin typeface="Garamond"/>
+              </a:rPr>
+              <a:t>The March supplement (ASEC) produces:</a:t>
+            </a:r>
+          </a:p>
+        </p:txBody>
+      </p:sp>
+      <p:sp>
+        <p:nvSpPr>
+          <p:cNvPr id="6" name="TextBox 5"/>
+          <p:cNvSpPr txBox="1"/>
           <p:nvPr/>
-        </p:nvCxnSpPr>
+        </p:nvSpPr>
         <p:spPr>
           <a:xfrm>
-            <a:off x="822960" y="2011680"/>
-            <a:ext cx="10607040" cy="0"/>
-          </a:xfrm>
-          <a:prstGeom prst="line">
-            <a:avLst/>
-          </a:prstGeom>
-          <a:ln w="12700">
-            <a:solidFill>
-              <a:srgbClr val="212529"/>
-            </a:solidFill>
-          </a:ln>
-          <a:effectLst/>
-        </p:spPr>
-        <p:style>
-          <a:lnRef idx="2">
-            <a:schemeClr val="accent1"/>
-          </a:lnRef>
-          <a:fillRef idx="0">
-            <a:schemeClr val="accent1"/>
-          </a:fillRef>
-          <a:effectRef idx="1">
-            <a:schemeClr val="accent1"/>
-          </a:effectRef>
-          <a:fontRef idx="minor">
-            <a:schemeClr val="tx1"/>
-          </a:fontRef>
-        </p:style>
-      </p:cxnSp>
-      <p:sp>
-        <p:nvSpPr>
-          <p:cNvPr id="8" name="TextBox 7"/>
-          <p:cNvSpPr txBox="1"/>
-          <p:nvPr/>
-        </p:nvSpPr>
-        <p:spPr>
-          <a:xfrm>
-            <a:off x="822960" y="2148840"/>
-            <a:ext cx="2743200" cy="365760"/>
+            <a:off x="1417320" y="4114800"/>
+            <a:ext cx="9966960" cy="914400"/>
           </a:xfrm>
           <a:prstGeom prst="rect">
             <a:avLst/>
@@ -3340,372 +3363,92 @@
           <a:p>
             <a:pPr>
               <a:lnSpc>
-                <a:spcPts val="1855"/>
+                <a:spcPts val="2432"/>
               </a:lnSpc>
+              <a:spcAft>
+                <a:spcPts val="600"/>
+              </a:spcAft>
             </a:pPr>
             <a:r>
-              <a:rPr sz="1450" b="0">
-                <a:solidFill>
-                  <a:srgbClr val="212529"/>
+              <a:rPr sz="1900" b="1">
+                <a:solidFill>
+                  <a:srgbClr val="102D5E"/>
                 </a:solidFill>
                 <a:latin typeface="Garamond"/>
               </a:rPr>
-              <a:t>Basic monthly interview</a:t>
-            </a:r>
-          </a:p>
-        </p:txBody>
-      </p:sp>
-      <p:sp>
-        <p:nvSpPr>
-          <p:cNvPr id="9" name="TextBox 8"/>
-          <p:cNvSpPr txBox="1"/>
-          <p:nvPr/>
-        </p:nvSpPr>
-        <p:spPr>
-          <a:xfrm>
-            <a:off x="3749039" y="2148840"/>
-            <a:ext cx="3931920" cy="365760"/>
-          </a:xfrm>
-          <a:prstGeom prst="rect">
-            <a:avLst/>
-          </a:prstGeom>
-          <a:noFill/>
-        </p:spPr>
-        <p:txBody>
-          <a:bodyPr wrap="square" lIns="0" rIns="0" tIns="0" bIns="0">
-            <a:spAutoFit/>
-          </a:bodyPr>
-          <a:lstStyle/>
+              <a:t>(a)  </a:t>
+            </a:r>
+            <a:r>
+              <a:rPr sz="1900" b="0">
+                <a:solidFill>
+                  <a:srgbClr val="212529"/>
+                </a:solidFill>
+                <a:latin typeface="Garamond"/>
+              </a:rPr>
+              <a:t>The official income and poverty statistics</a:t>
+            </a:r>
+          </a:p>
           <a:p>
             <a:pPr>
               <a:lnSpc>
-                <a:spcPts val="1855"/>
+                <a:spcPts val="2432"/>
               </a:lnSpc>
+              <a:spcAft>
+                <a:spcPts val="600"/>
+              </a:spcAft>
             </a:pPr>
             <a:r>
-              <a:rPr sz="1450" b="0">
-                <a:solidFill>
-                  <a:srgbClr val="212529"/>
+              <a:rPr sz="1900" b="1">
+                <a:solidFill>
+                  <a:srgbClr val="102D5E"/>
                 </a:solidFill>
                 <a:latin typeface="Garamond"/>
               </a:rPr>
-              <a:t>Labor force status in the reference week, occupation, hours</a:t>
-            </a:r>
-          </a:p>
-        </p:txBody>
-      </p:sp>
-      <p:sp>
-        <p:nvSpPr>
-          <p:cNvPr id="10" name="TextBox 9"/>
-          <p:cNvSpPr txBox="1"/>
-          <p:nvPr/>
-        </p:nvSpPr>
-        <p:spPr>
-          <a:xfrm>
-            <a:off x="7863840" y="2148840"/>
-            <a:ext cx="3566160" cy="365760"/>
-          </a:xfrm>
-          <a:prstGeom prst="rect">
-            <a:avLst/>
-          </a:prstGeom>
-          <a:noFill/>
-        </p:spPr>
-        <p:txBody>
-          <a:bodyPr wrap="square" lIns="0" rIns="0" tIns="0" bIns="0">
-            <a:spAutoFit/>
-          </a:bodyPr>
-          <a:lstStyle/>
+              <a:t>(b)  </a:t>
+            </a:r>
+            <a:r>
+              <a:rPr sz="1900" b="0">
+                <a:solidFill>
+                  <a:srgbClr val="212529"/>
+                </a:solidFill>
+                <a:latin typeface="Garamond"/>
+              </a:rPr>
+              <a:t>The official health-insurance coverage statistics</a:t>
+            </a:r>
+          </a:p>
           <a:p>
             <a:pPr>
               <a:lnSpc>
-                <a:spcPts val="1855"/>
+                <a:spcPts val="2432"/>
               </a:lnSpc>
+              <a:spcAft>
+                <a:spcPts val="600"/>
+              </a:spcAft>
             </a:pPr>
             <a:r>
-              <a:rPr sz="1450" b="0">
-                <a:solidFill>
-                  <a:srgbClr val="212529"/>
+              <a:rPr sz="1900" b="1">
+                <a:solidFill>
+                  <a:srgbClr val="102D5E"/>
                 </a:solidFill>
                 <a:latin typeface="Garamond"/>
               </a:rPr>
-              <a:t>The official monthly unemployment rate, employment and earnings statistics</a:t>
-            </a:r>
-          </a:p>
-        </p:txBody>
-      </p:sp>
-      <p:sp>
-        <p:nvSpPr>
-          <p:cNvPr id="11" name="TextBox 10"/>
-          <p:cNvSpPr txBox="1"/>
-          <p:nvPr/>
-        </p:nvSpPr>
-        <p:spPr>
-          <a:xfrm>
-            <a:off x="822960" y="3108960"/>
-            <a:ext cx="2743200" cy="365760"/>
-          </a:xfrm>
-          <a:prstGeom prst="rect">
-            <a:avLst/>
-          </a:prstGeom>
-          <a:noFill/>
-        </p:spPr>
-        <p:txBody>
-          <a:bodyPr wrap="square" lIns="0" rIns="0" tIns="0" bIns="0">
-            <a:spAutoFit/>
-          </a:bodyPr>
-          <a:lstStyle/>
-          <a:p>
-            <a:pPr>
-              <a:lnSpc>
-                <a:spcPts val="1855"/>
-              </a:lnSpc>
-            </a:pPr>
-            <a:r>
-              <a:rPr sz="1450" b="0">
+              <a:t>(c)  </a:t>
+            </a:r>
+            <a:r>
+              <a:rPr sz="1900" b="0">
                 <a:solidFill>
                   <a:srgbClr val="212529"/>
                 </a:solidFill>
                 <a:latin typeface="Garamond"/>
               </a:rPr>
-              <a:t>Topical supplements</a:t>
-            </a:r>
-          </a:p>
-        </p:txBody>
-      </p:sp>
-      <p:sp>
-        <p:nvSpPr>
-          <p:cNvPr id="12" name="TextBox 11"/>
-          <p:cNvSpPr txBox="1"/>
-          <p:nvPr/>
-        </p:nvSpPr>
-        <p:spPr>
-          <a:xfrm>
-            <a:off x="3749039" y="3108960"/>
-            <a:ext cx="3931920" cy="365760"/>
-          </a:xfrm>
-          <a:prstGeom prst="rect">
-            <a:avLst/>
-          </a:prstGeom>
-          <a:noFill/>
-        </p:spPr>
-        <p:txBody>
-          <a:bodyPr wrap="square" lIns="0" rIns="0" tIns="0" bIns="0">
-            <a:spAutoFit/>
-          </a:bodyPr>
-          <a:lstStyle/>
-          <a:p>
-            <a:pPr>
-              <a:lnSpc>
-                <a:spcPts val="1855"/>
-              </a:lnSpc>
-            </a:pPr>
-            <a:r>
-              <a:rPr sz="1450" b="0">
-                <a:solidFill>
-                  <a:srgbClr val="212529"/>
-                </a:solidFill>
-                <a:latin typeface="Garamond"/>
-              </a:rPr>
-              <a:t>School enrollment (Oct.), voting (Nov.), tobacco, computer use</a:t>
-            </a:r>
-          </a:p>
-        </p:txBody>
-      </p:sp>
-      <p:sp>
-        <p:nvSpPr>
-          <p:cNvPr id="13" name="TextBox 12"/>
-          <p:cNvSpPr txBox="1"/>
-          <p:nvPr/>
-        </p:nvSpPr>
-        <p:spPr>
-          <a:xfrm>
-            <a:off x="7863840" y="3108960"/>
-            <a:ext cx="3566160" cy="365760"/>
-          </a:xfrm>
-          <a:prstGeom prst="rect">
-            <a:avLst/>
-          </a:prstGeom>
-          <a:noFill/>
-        </p:spPr>
-        <p:txBody>
-          <a:bodyPr wrap="square" lIns="0" rIns="0" tIns="0" bIns="0">
-            <a:spAutoFit/>
-          </a:bodyPr>
-          <a:lstStyle/>
-          <a:p>
-            <a:pPr>
-              <a:lnSpc>
-                <a:spcPts val="1855"/>
-              </a:lnSpc>
-            </a:pPr>
-            <a:r>
-              <a:rPr sz="1450" b="0">
-                <a:solidFill>
-                  <a:srgbClr val="212529"/>
-                </a:solidFill>
-                <a:latin typeface="Garamond"/>
-              </a:rPr>
-              <a:t>Topic-specific official statistics</a:t>
-            </a:r>
-          </a:p>
-        </p:txBody>
-      </p:sp>
-      <p:sp>
-        <p:nvSpPr>
-          <p:cNvPr id="14" name="TextBox 13"/>
-          <p:cNvSpPr txBox="1"/>
-          <p:nvPr/>
-        </p:nvSpPr>
-        <p:spPr>
-          <a:xfrm>
-            <a:off x="822960" y="4069080"/>
-            <a:ext cx="2743200" cy="365760"/>
-          </a:xfrm>
-          <a:prstGeom prst="rect">
-            <a:avLst/>
-          </a:prstGeom>
-          <a:noFill/>
-        </p:spPr>
-        <p:txBody>
-          <a:bodyPr wrap="square" lIns="0" rIns="0" tIns="0" bIns="0">
-            <a:spAutoFit/>
-          </a:bodyPr>
-          <a:lstStyle/>
-          <a:p>
-            <a:pPr>
-              <a:lnSpc>
-                <a:spcPts val="1855"/>
-              </a:lnSpc>
-            </a:pPr>
-            <a:r>
-              <a:rPr sz="1450" b="0">
-                <a:solidFill>
-                  <a:srgbClr val="212529"/>
-                </a:solidFill>
-                <a:latin typeface="Garamond"/>
-              </a:rPr>
-              <a:t>March supplement (ASEC)</a:t>
-            </a:r>
-          </a:p>
-        </p:txBody>
-      </p:sp>
-      <p:sp>
-        <p:nvSpPr>
-          <p:cNvPr id="15" name="TextBox 14"/>
-          <p:cNvSpPr txBox="1"/>
-          <p:nvPr/>
-        </p:nvSpPr>
-        <p:spPr>
-          <a:xfrm>
-            <a:off x="3749039" y="4069080"/>
-            <a:ext cx="3931920" cy="365760"/>
-          </a:xfrm>
-          <a:prstGeom prst="rect">
-            <a:avLst/>
-          </a:prstGeom>
-          <a:noFill/>
-        </p:spPr>
-        <p:txBody>
-          <a:bodyPr wrap="square" lIns="0" rIns="0" tIns="0" bIns="0">
-            <a:spAutoFit/>
-          </a:bodyPr>
-          <a:lstStyle/>
-          <a:p>
-            <a:pPr>
-              <a:lnSpc>
-                <a:spcPts val="1855"/>
-              </a:lnSpc>
-            </a:pPr>
-            <a:r>
-              <a:rPr sz="1450" b="0">
-                <a:solidFill>
-                  <a:srgbClr val="212529"/>
-                </a:solidFill>
-                <a:latin typeface="Garamond"/>
-              </a:rPr>
-              <a:t>The previous calendar year, from the longest job to weeks, income and benefits</a:t>
-            </a:r>
-          </a:p>
-        </p:txBody>
-      </p:sp>
-      <p:sp>
-        <p:nvSpPr>
-          <p:cNvPr id="16" name="TextBox 15"/>
-          <p:cNvSpPr txBox="1"/>
-          <p:nvPr/>
-        </p:nvSpPr>
-        <p:spPr>
-          <a:xfrm>
-            <a:off x="7863840" y="4069080"/>
-            <a:ext cx="3566160" cy="365760"/>
-          </a:xfrm>
-          <a:prstGeom prst="rect">
-            <a:avLst/>
-          </a:prstGeom>
-          <a:noFill/>
-        </p:spPr>
-        <p:txBody>
-          <a:bodyPr wrap="square" lIns="0" rIns="0" tIns="0" bIns="0">
-            <a:spAutoFit/>
-          </a:bodyPr>
-          <a:lstStyle/>
-          <a:p>
-            <a:pPr>
-              <a:lnSpc>
-                <a:spcPts val="1855"/>
-              </a:lnSpc>
-            </a:pPr>
-            <a:r>
-              <a:rPr sz="1450" b="0">
-                <a:solidFill>
-                  <a:srgbClr val="212529"/>
-                </a:solidFill>
-                <a:latin typeface="Garamond"/>
-              </a:rPr>
-              <a:t>Official income, poverty and health-insurance statistics, and our retrospective measure</a:t>
-            </a:r>
-          </a:p>
-        </p:txBody>
-      </p:sp>
-      <p:cxnSp>
-        <p:nvCxnSpPr>
-          <p:cNvPr id="17" name="Connector 16"/>
-          <p:cNvCxnSpPr/>
-          <p:nvPr/>
-        </p:nvCxnSpPr>
-        <p:spPr>
-          <a:xfrm>
-            <a:off x="822960" y="5047488"/>
-            <a:ext cx="10607040" cy="0"/>
-          </a:xfrm>
-          <a:prstGeom prst="line">
-            <a:avLst/>
-          </a:prstGeom>
-          <a:ln w="12700">
-            <a:solidFill>
-              <a:srgbClr val="212529"/>
-            </a:solidFill>
-          </a:ln>
-          <a:effectLst/>
-        </p:spPr>
-        <p:style>
-          <a:lnRef idx="2">
-            <a:schemeClr val="accent1"/>
-          </a:lnRef>
-          <a:fillRef idx="0">
-            <a:schemeClr val="accent1"/>
-          </a:fillRef>
-          <a:effectRef idx="1">
-            <a:schemeClr val="accent1"/>
-          </a:effectRef>
-          <a:fontRef idx="minor">
-            <a:schemeClr val="tx1"/>
-          </a:fontRef>
-        </p:style>
-      </p:cxnSp>
-      <p:sp>
-        <p:nvSpPr>
-          <p:cNvPr id="18" name="Rounded Rectangle 17">
+              <a:t>Our retrospective measure: the longest job held last year, with weeks worked, earnings and benefits</a:t>
+            </a:r>
+          </a:p>
+        </p:txBody>
+      </p:sp>
+      <p:sp>
+        <p:nvSpPr>
+          <p:cNvPr id="7" name="Rounded Rectangle 6">
             <a:hlinkClick action="ppaction://hlinksldjump" r:id="rId2"/>
           </p:cNvPr>
           <p:cNvSpPr/>

</xml_diff>